<commit_message>
feat: Update PPTX and DOCX templates to include additional attributes for improved layout and styling
</commit_message>
<xml_diff>
--- a/public/sample_uploads/portfolio_report_templates/brand_template_emerald.pptx
+++ b/public/sample_uploads/portfolio_report_templates/brand_template_emerald.pptx
@@ -29,6 +29,8 @@
         <a:xfrm>
           <a:off x="0" y="0"/>
           <a:ext cx="0" cy="0"/>
+          <a:chOff x="0" y="0"/>
+          <a:chExt cx="0" cy="0"/>
         </a:xfrm>
       </p:grpSpPr>
     </p:spTree>
@@ -56,10 +58,13 @@
         <a:xfrm>
           <a:off x="0" y="0"/>
           <a:ext cx="0" cy="0"/>
+          <a:chOff x="0" y="0"/>
+          <a:chExt cx="0" cy="0"/>
         </a:xfrm>
       </p:grpSpPr>
     </p:spTree>
   </p:cSld>
+  <p:clrMap bg1="lt1" tx1="dk1" bg2="lt2" tx2="dk2" accent1="accent1" accent2="accent2" accent3="accent3" accent4="accent4" accent5="accent5" accent6="accent6" hlink="hlink" folHlink="folHlink"/>
   <p:sldLayoutIdLst>
     <p:sldLayoutId id="2147483649" r:id="rId1"/>
   </p:sldLayoutIdLst>
@@ -92,6 +97,8 @@
         <a:xfrm>
           <a:off x="0" y="0"/>
           <a:ext cx="0" cy="0"/>
+          <a:chOff x="0" y="0"/>
+          <a:chExt cx="0" cy="0"/>
         </a:xfrm>
       </p:grpSpPr>
       <p:sp>
@@ -473,7 +480,7 @@
                   <a:srgbClr val="94A3B8"/>
                 </a:solidFill>
               </a:rPr>
-              <a:t>Generated 29 May 2026</a:t>
+              <a:t>Generated 12 Jun 2026</a:t>
             </a:r>
           </a:p>
         </p:txBody>
@@ -498,6 +505,8 @@
         <a:xfrm>
           <a:off x="0" y="0"/>
           <a:ext cx="0" cy="0"/>
+          <a:chOff x="0" y="0"/>
+          <a:chExt cx="0" cy="0"/>
         </a:xfrm>
       </p:grpSpPr>
       <p:sp>
@@ -1164,6 +1173,8 @@
         <a:xfrm>
           <a:off x="0" y="0"/>
           <a:ext cx="0" cy="0"/>
+          <a:chOff x="0" y="0"/>
+          <a:chExt cx="0" cy="0"/>
         </a:xfrm>
       </p:grpSpPr>
       <p:sp>
@@ -1582,6 +1593,8 @@
         <a:xfrm>
           <a:off x="0" y="0"/>
           <a:ext cx="0" cy="0"/>
+          <a:chOff x="0" y="0"/>
+          <a:chExt cx="0" cy="0"/>
         </a:xfrm>
       </p:grpSpPr>
       <p:sp>
@@ -3089,6 +3102,8 @@
         <a:xfrm>
           <a:off x="0" y="0"/>
           <a:ext cx="0" cy="0"/>
+          <a:chOff x="0" y="0"/>
+          <a:chExt cx="0" cy="0"/>
         </a:xfrm>
       </p:grpSpPr>
       <p:sp>

</xml_diff>